<commit_message>
feat: Add Gemini fallback, update Firebase, and final presentation PDF
</commit_message>
<xml_diff>
--- a/docs/FairFlow_Solution_Challenge_2026_Submission.pptx
+++ b/docs/FairFlow_Solution_Challenge_2026_Submission.pptx
@@ -16428,204 +16428,9 @@
           <a:chExt cx="0" cy="0"/>
         </a:xfrm>
       </p:grpSpPr>
-      <p:sp>
-        <p:nvSpPr>
-          <p:cNvPr id="175" name="Google Shape;175;p37"/>
-          <p:cNvSpPr txBox="1"/>
-          <p:nvPr/>
-        </p:nvSpPr>
-        <p:spPr>
-          <a:xfrm>
-            <a:off x="146600" y="843000"/>
-            <a:ext cx="8833200" cy="635400"/>
-          </a:xfrm>
-          <a:prstGeom prst="rect">
-            <a:avLst/>
-          </a:prstGeom>
-          <a:noFill/>
-          <a:ln>
-            <a:noFill/>
-          </a:ln>
-        </p:spPr>
-        <p:txBody>
-          <a:bodyPr anchorCtr="0" anchor="t" bIns="91425" lIns="91425" spcFirstLastPara="1" rIns="91425" wrap="square" tIns="91425">
-            <a:noAutofit/>
-          </a:bodyPr>
-          <a:lstStyle/>
-          <a:p>
-            <a:pPr indent="0" lvl="0" marL="0" marR="0" rtl="0" algn="l">
-              <a:lnSpc>
-                <a:spcPct val="100000"/>
-              </a:lnSpc>
-              <a:spcBef>
-                <a:spcPts val="0"/>
-              </a:spcBef>
-              <a:spcAft>
-                <a:spcPts val="0"/>
-              </a:spcAft>
-              <a:buClr>
-                <a:srgbClr val="000000"/>
-              </a:buClr>
-              <a:buSzPts val="1800"/>
-              <a:buFont typeface="Arial"/>
-              <a:buNone/>
-            </a:pPr>
-            <a:r>
-              <a:rPr sz="2800" b="1">
-                <a:solidFill>
-                  <a:srgbClr val="1F2937"/>
-                </a:solidFill>
-                <a:latin typeface="Calibri"/>
-              </a:rPr>
-              <a:t>Provide links to your:</a:t>
-            </a:r>
-            <a:endParaRPr b="0" i="0" sz="1800" u="none" cap="none" strike="noStrike">
-              <a:solidFill>
-                <a:srgbClr val="000000"/>
-              </a:solidFill>
-              <a:latin typeface="Google Sans"/>
-              <a:ea typeface="Google Sans"/>
-              <a:cs typeface="Google Sans"/>
-              <a:sym typeface="Google Sans"/>
-            </a:endParaRPr>
-          </a:p>
-          <a:p>
-            <a:r>
-              <a:rPr sz="800" b="0">
-                <a:solidFill>
-                  <a:srgbClr val="334155"/>
-                </a:solidFill>
-                <a:latin typeface="Calibri"/>
-              </a:rPr>
-              <a:t/>
-            </a:r>
-          </a:p>
-          <a:p>
-            <a:r>
-              <a:rPr sz="1900" b="1">
-                <a:solidFill>
-                  <a:srgbClr val="1F2937"/>
-                </a:solidFill>
-                <a:latin typeface="Calibri"/>
-              </a:rPr>
-              <a:t>GitHub Public Repository</a:t>
-            </a:r>
-          </a:p>
-          <a:p>
-            <a:r>
-              <a:rPr sz="1600" b="0">
-                <a:solidFill>
-                  <a:srgbClr val="2563EB"/>
-                </a:solidFill>
-                <a:latin typeface="Calibri"/>
-              </a:rPr>
-              <a:t>https://github.com/Akshat-coder2106/FairFlow-AI</a:t>
-            </a:r>
-          </a:p>
-          <a:p>
-            <a:r>
-              <a:rPr sz="700" b="0">
-                <a:solidFill>
-                  <a:srgbClr val="334155"/>
-                </a:solidFill>
-                <a:latin typeface="Calibri"/>
-              </a:rPr>
-              <a:t/>
-            </a:r>
-          </a:p>
-          <a:p>
-            <a:r>
-              <a:rPr sz="1900" b="1">
-                <a:solidFill>
-                  <a:srgbClr val="1F2937"/>
-                </a:solidFill>
-                <a:latin typeface="Calibri"/>
-              </a:rPr>
-              <a:t>Demo Video Link (3 Minutes)</a:t>
-            </a:r>
-          </a:p>
-          <a:p>
-            <a:r>
-              <a:rPr sz="1600" b="0">
-                <a:solidFill>
-                  <a:srgbClr val="334155"/>
-                </a:solidFill>
-                <a:latin typeface="Calibri"/>
-              </a:rPr>
-              <a:t>To be attached before final submission</a:t>
-            </a:r>
-          </a:p>
-          <a:p>
-            <a:r>
-              <a:rPr sz="700" b="0">
-                <a:solidFill>
-                  <a:srgbClr val="334155"/>
-                </a:solidFill>
-                <a:latin typeface="Calibri"/>
-              </a:rPr>
-              <a:t/>
-            </a:r>
-          </a:p>
-          <a:p>
-            <a:r>
-              <a:rPr sz="1900" b="1">
-                <a:solidFill>
-                  <a:srgbClr val="1F2937"/>
-                </a:solidFill>
-                <a:latin typeface="Calibri"/>
-              </a:rPr>
-              <a:t>MVP Link</a:t>
-            </a:r>
-          </a:p>
-          <a:p>
-            <a:r>
-              <a:rPr sz="1600" b="0">
-                <a:solidFill>
-                  <a:srgbClr val="334155"/>
-                </a:solidFill>
-                <a:latin typeface="Calibri"/>
-              </a:rPr>
-              <a:t>http://127.0.0.1:3000 (local) | Cloud Run staging: publishing</a:t>
-            </a:r>
-          </a:p>
-          <a:p>
-            <a:r>
-              <a:rPr sz="700" b="0">
-                <a:solidFill>
-                  <a:srgbClr val="334155"/>
-                </a:solidFill>
-                <a:latin typeface="Calibri"/>
-              </a:rPr>
-              <a:t/>
-            </a:r>
-          </a:p>
-          <a:p>
-            <a:r>
-              <a:rPr sz="1900" b="1">
-                <a:solidFill>
-                  <a:srgbClr val="1F2937"/>
-                </a:solidFill>
-                <a:latin typeface="Calibri"/>
-              </a:rPr>
-              <a:t>Working Prototype Link</a:t>
-            </a:r>
-          </a:p>
-          <a:p>
-            <a:r>
-              <a:rPr sz="1600" b="0">
-                <a:solidFill>
-                  <a:srgbClr val="334155"/>
-                </a:solidFill>
-                <a:latin typeface="Calibri"/>
-              </a:rPr>
-              <a:t>Same repository includes frontend, backend, WASM, sample datasets, and docs</a:t>
-            </a:r>
-          </a:p>
-        </p:txBody>
-      </p:sp>
       <p:pic>
         <p:nvPicPr>
-          <p:cNvPr id="176" name="Google Shape;176;p37" title="frameeeee.png"/>
+          <p:cNvPr id="175" name="Google Shape;175;p37" title="frameeeee.png"/>
           <p:cNvPicPr preferRelativeResize="0"/>
           <p:nvPr/>
         </p:nvPicPr>
@@ -16651,6 +16456,201 @@
           </a:ln>
         </p:spPr>
       </p:pic>
+      <p:sp>
+        <p:nvSpPr>
+          <p:cNvPr id="176" name="Google Shape;176;p37"/>
+          <p:cNvSpPr txBox="1"/>
+          <p:nvPr/>
+        </p:nvSpPr>
+        <p:spPr>
+          <a:xfrm>
+            <a:off x="146600" y="843000"/>
+            <a:ext cx="8833200" cy="635400"/>
+          </a:xfrm>
+          <a:prstGeom prst="rect">
+            <a:avLst/>
+          </a:prstGeom>
+          <a:noFill/>
+          <a:ln>
+            <a:noFill/>
+          </a:ln>
+        </p:spPr>
+        <p:txBody>
+          <a:bodyPr anchorCtr="0" anchor="t" bIns="91425" lIns="91425" spcFirstLastPara="1" rIns="91425" wrap="square" tIns="91425">
+            <a:noAutofit/>
+          </a:bodyPr>
+          <a:lstStyle/>
+          <a:p>
+            <a:pPr indent="0" lvl="0" marL="0" marR="0" rtl="0" algn="l">
+              <a:lnSpc>
+                <a:spcPct val="100000"/>
+              </a:lnSpc>
+              <a:spcBef>
+                <a:spcPts val="0"/>
+              </a:spcBef>
+              <a:spcAft>
+                <a:spcPts val="0"/>
+              </a:spcAft>
+              <a:buClr>
+                <a:srgbClr val="000000"/>
+              </a:buClr>
+              <a:buSzPts val="1800"/>
+              <a:buFont typeface="Arial"/>
+              <a:buNone/>
+            </a:pPr>
+            <a:r>
+              <a:rPr sz="2800" b="1">
+                <a:solidFill>
+                  <a:srgbClr val="1F2937"/>
+                </a:solidFill>
+                <a:latin typeface="Calibri"/>
+              </a:rPr>
+              <a:t>Provide links to your:</a:t>
+            </a:r>
+            <a:endParaRPr b="0" i="0" sz="1800" u="none" cap="none" strike="noStrike">
+              <a:solidFill>
+                <a:srgbClr val="000000"/>
+              </a:solidFill>
+              <a:latin typeface="Google Sans"/>
+              <a:ea typeface="Google Sans"/>
+              <a:cs typeface="Google Sans"/>
+              <a:sym typeface="Google Sans"/>
+            </a:endParaRPr>
+          </a:p>
+          <a:p>
+            <a:r>
+              <a:rPr sz="800" b="0">
+                <a:solidFill>
+                  <a:srgbClr val="334155"/>
+                </a:solidFill>
+                <a:latin typeface="Calibri"/>
+              </a:rPr>
+              <a:t/>
+            </a:r>
+          </a:p>
+          <a:p>
+            <a:r>
+              <a:rPr sz="1900" b="1">
+                <a:solidFill>
+                  <a:srgbClr val="1F2937"/>
+                </a:solidFill>
+                <a:latin typeface="Calibri"/>
+              </a:rPr>
+              <a:t>GitHub Public Repository</a:t>
+            </a:r>
+          </a:p>
+          <a:p>
+            <a:r>
+              <a:rPr sz="1600" b="0">
+                <a:solidFill>
+                  <a:srgbClr val="2563EB"/>
+                </a:solidFill>
+                <a:latin typeface="Calibri"/>
+              </a:rPr>
+              <a:t>https://github.com/Akshat-coder2106/FairFlow-AI</a:t>
+            </a:r>
+          </a:p>
+          <a:p>
+            <a:r>
+              <a:rPr sz="700" b="0">
+                <a:solidFill>
+                  <a:srgbClr val="334155"/>
+                </a:solidFill>
+                <a:latin typeface="Calibri"/>
+              </a:rPr>
+              <a:t/>
+            </a:r>
+          </a:p>
+          <a:p>
+            <a:r>
+              <a:rPr sz="1900" b="1">
+                <a:solidFill>
+                  <a:srgbClr val="1F2937"/>
+                </a:solidFill>
+                <a:latin typeface="Calibri"/>
+              </a:rPr>
+              <a:t>Demo Video Link (3 Minutes)</a:t>
+            </a:r>
+          </a:p>
+          <a:p>
+            <a:r>
+              <a:rPr sz="1600" b="0">
+                <a:solidFill>
+                  <a:srgbClr val="334155"/>
+                </a:solidFill>
+                <a:latin typeface="Calibri"/>
+              </a:rPr>
+              <a:t>To be attached before final submission</a:t>
+            </a:r>
+          </a:p>
+          <a:p>
+            <a:r>
+              <a:rPr sz="700" b="0">
+                <a:solidFill>
+                  <a:srgbClr val="334155"/>
+                </a:solidFill>
+                <a:latin typeface="Calibri"/>
+              </a:rPr>
+              <a:t/>
+            </a:r>
+          </a:p>
+          <a:p>
+            <a:r>
+              <a:rPr sz="1900" b="1">
+                <a:solidFill>
+                  <a:srgbClr val="1F2937"/>
+                </a:solidFill>
+                <a:latin typeface="Calibri"/>
+              </a:rPr>
+              <a:t>MVP Link</a:t>
+            </a:r>
+          </a:p>
+          <a:p>
+            <a:r>
+              <a:rPr sz="1600" b="0">
+                <a:solidFill>
+                  <a:srgbClr val="334155"/>
+                </a:solidFill>
+                <a:latin typeface="Calibri"/>
+              </a:rPr>
+              <a:t>http://127.0.0.1:3000 (local) | Cloud Run staging: publishing</a:t>
+            </a:r>
+          </a:p>
+          <a:p>
+            <a:r>
+              <a:rPr sz="700" b="0">
+                <a:solidFill>
+                  <a:srgbClr val="334155"/>
+                </a:solidFill>
+                <a:latin typeface="Calibri"/>
+              </a:rPr>
+              <a:t/>
+            </a:r>
+          </a:p>
+          <a:p>
+            <a:r>
+              <a:rPr sz="1900" b="1">
+                <a:solidFill>
+                  <a:srgbClr val="1F2937"/>
+                </a:solidFill>
+                <a:latin typeface="Calibri"/>
+              </a:rPr>
+              <a:t>Working Prototype Link</a:t>
+            </a:r>
+          </a:p>
+          <a:p>
+            <a:r>
+              <a:rPr sz="1600" b="0">
+                <a:solidFill>
+                  <a:srgbClr val="334155"/>
+                </a:solidFill>
+                <a:latin typeface="Calibri"/>
+              </a:rPr>
+              <a:t>Same repository includes frontend, backend, WASM, sample datasets, and docs</a:t>
+            </a:r>
+          </a:p>
+        </p:txBody>
+      </p:sp>
     </p:spTree>
   </p:cSld>
   <p:clrMapOvr>
@@ -17098,6 +17098,12 @@
               <a:buNone/>
             </a:pPr>
             <a:r>
+              <a:rPr sz="100" b="0">
+                <a:solidFill>
+                  <a:srgbClr val="1F2937"/>
+                </a:solidFill>
+                <a:latin typeface="Calibri"/>
+              </a:rPr>
               <a:t/>
             </a:r>
             <a:endParaRPr/>
@@ -19901,72 +19907,9 @@
           <a:chExt cx="0" cy="0"/>
         </a:xfrm>
       </p:grpSpPr>
-      <p:sp>
-        <p:nvSpPr>
-          <p:cNvPr id="151" name="Google Shape;151;p33"/>
-          <p:cNvSpPr txBox="1"/>
-          <p:nvPr/>
-        </p:nvSpPr>
-        <p:spPr>
-          <a:xfrm>
-            <a:off x="158825" y="855225"/>
-            <a:ext cx="8784300" cy="1128300"/>
-          </a:xfrm>
-          <a:prstGeom prst="rect">
-            <a:avLst/>
-          </a:prstGeom>
-          <a:noFill/>
-          <a:ln>
-            <a:noFill/>
-          </a:ln>
-        </p:spPr>
-        <p:txBody>
-          <a:bodyPr anchorCtr="0" anchor="t" bIns="91425" lIns="91425" spcFirstLastPara="1" rIns="91425" wrap="square" tIns="91425">
-            <a:noAutofit/>
-          </a:bodyPr>
-          <a:lstStyle/>
-          <a:p>
-            <a:pPr indent="0" lvl="0" marL="0" marR="0" rtl="0" algn="l">
-              <a:lnSpc>
-                <a:spcPct val="100000"/>
-              </a:lnSpc>
-              <a:spcBef>
-                <a:spcPts val="0"/>
-              </a:spcBef>
-              <a:spcAft>
-                <a:spcPts val="0"/>
-              </a:spcAft>
-              <a:buClr>
-                <a:srgbClr val="000000"/>
-              </a:buClr>
-              <a:buSzPts val="1800"/>
-              <a:buFont typeface="Arial"/>
-              <a:buNone/>
-            </a:pPr>
-            <a:r>
-              <a:rPr sz="3000" b="1">
-                <a:solidFill>
-                  <a:srgbClr val="1F2937"/>
-                </a:solidFill>
-                <a:latin typeface="Calibri"/>
-              </a:rPr>
-              <a:t>Technologies Used in the Solution</a:t>
-            </a:r>
-            <a:endParaRPr b="0" i="0" sz="1200" u="none" cap="none" strike="noStrike">
-              <a:solidFill>
-                <a:srgbClr val="000000"/>
-              </a:solidFill>
-              <a:latin typeface="Google Sans"/>
-              <a:ea typeface="Google Sans"/>
-              <a:cs typeface="Google Sans"/>
-              <a:sym typeface="Google Sans"/>
-            </a:endParaRPr>
-          </a:p>
-        </p:txBody>
-      </p:sp>
       <p:pic>
         <p:nvPicPr>
-          <p:cNvPr id="152" name="Google Shape;152;p33" title="frameeeee.png"/>
+          <p:cNvPr id="151" name="Google Shape;151;p33" title="frameeeee.png"/>
           <p:cNvPicPr preferRelativeResize="0"/>
           <p:nvPr/>
         </p:nvPicPr>
@@ -19992,6 +19935,69 @@
           </a:ln>
         </p:spPr>
       </p:pic>
+      <p:sp>
+        <p:nvSpPr>
+          <p:cNvPr id="152" name="Google Shape;152;p33"/>
+          <p:cNvSpPr txBox="1"/>
+          <p:nvPr/>
+        </p:nvSpPr>
+        <p:spPr>
+          <a:xfrm>
+            <a:off x="158825" y="855225"/>
+            <a:ext cx="8784300" cy="1128300"/>
+          </a:xfrm>
+          <a:prstGeom prst="rect">
+            <a:avLst/>
+          </a:prstGeom>
+          <a:noFill/>
+          <a:ln>
+            <a:noFill/>
+          </a:ln>
+        </p:spPr>
+        <p:txBody>
+          <a:bodyPr anchorCtr="0" anchor="t" bIns="91425" lIns="91425" spcFirstLastPara="1" rIns="91425" wrap="square" tIns="91425">
+            <a:noAutofit/>
+          </a:bodyPr>
+          <a:lstStyle/>
+          <a:p>
+            <a:pPr indent="0" lvl="0" marL="0" marR="0" rtl="0" algn="l">
+              <a:lnSpc>
+                <a:spcPct val="100000"/>
+              </a:lnSpc>
+              <a:spcBef>
+                <a:spcPts val="0"/>
+              </a:spcBef>
+              <a:spcAft>
+                <a:spcPts val="0"/>
+              </a:spcAft>
+              <a:buClr>
+                <a:srgbClr val="000000"/>
+              </a:buClr>
+              <a:buSzPts val="1800"/>
+              <a:buFont typeface="Arial"/>
+              <a:buNone/>
+            </a:pPr>
+            <a:r>
+              <a:rPr sz="3000" b="1">
+                <a:solidFill>
+                  <a:srgbClr val="1F2937"/>
+                </a:solidFill>
+                <a:latin typeface="Calibri"/>
+              </a:rPr>
+              <a:t>Technologies Used in the Solution</a:t>
+            </a:r>
+            <a:endParaRPr b="0" i="0" sz="1200" u="none" cap="none" strike="noStrike">
+              <a:solidFill>
+                <a:srgbClr val="000000"/>
+              </a:solidFill>
+              <a:latin typeface="Google Sans"/>
+              <a:ea typeface="Google Sans"/>
+              <a:cs typeface="Google Sans"/>
+              <a:sym typeface="Google Sans"/>
+            </a:endParaRPr>
+          </a:p>
+        </p:txBody>
+      </p:sp>
       <p:graphicFrame>
         <p:nvGraphicFramePr>
           <p:cNvPr id="153" name="Table 152"/>

</xml_diff>